<commit_message>
Update decks to LIKA Nexus branding and latest filename/links
</commit_message>
<xml_diff>
--- a/LIKA_Pitch_Deck.pptx
+++ b/LIKA_Pitch_Deck.pptx
@@ -1426,14 +1426,14 @@
           <a:p>
             <a:pPr algn="l"/>
             <a:r>
-              <a:rPr lang="th-TH" sz="3400" b="1" i="0" dirty="0">
+              <a:rPr lang="th-TH" sz="3800" b="1" i="0" dirty="0">
                 <a:solidFill>
                   <a:srgbClr val="e5edff"/>
                 </a:solidFill>
                 <a:latin typeface="Tahoma"/>
                 <a:cs typeface="Tahoma"/>
               </a:rPr>
-              <a:t>LIKA GeoBio-Nexus</a:t>
+              <a:t>LIKA Nexus</a:t>
             </a:r>
           </a:p>
         </p:txBody>
@@ -5280,7 +5280,7 @@
                 <a:latin typeface="Tahoma"/>
                 <a:cs typeface="Tahoma"/>
               </a:rPr>
-              <a:t>LIKA GeoBio-Nexus</a:t>
+              <a:t>LIKA Nexus</a:t>
             </a:r>
           </a:p>
         </p:txBody>
@@ -7832,7 +7832,7 @@
                 <a:latin typeface="Tahoma"/>
                 <a:cs typeface="Tahoma"/>
               </a:rPr>
-              <a:t>⭐ lika-geobio-nexus.html</a:t>
+              <a:t>⭐ lika-nexus.html</a:t>
             </a:r>
           </a:p>
         </p:txBody>

</xml_diff>